<commit_message>
Finalize showcase narration with current data patient feedback and partner invitation
</commit_message>
<xml_diff>
--- a/submission/PathwayAI_Final_Backup_Slides.pptx
+++ b/submission/PathwayAI_Final_Backup_Slides.pptx
@@ -3172,7 +3172,7 @@
   <p:clrMapOvr>
     <a:masterClrMapping/>
   </p:clrMapOvr>
-  <p:transition advClick="1" advTm="25000"/>
+  <p:transition advClick="1" advTm="22000"/>
 </p:sld>
 </file>
 
@@ -3215,7 +3215,7 @@
   <p:clrMapOvr>
     <a:masterClrMapping/>
   </p:clrMapOvr>
-  <p:transition advClick="1" advTm="25000"/>
+  <p:transition advClick="1" advTm="34000"/>
 </p:sld>
 </file>
 
@@ -3258,7 +3258,7 @@
   <p:clrMapOvr>
     <a:masterClrMapping/>
   </p:clrMapOvr>
-  <p:transition advClick="1" advTm="35000"/>
+  <p:transition advClick="1" advTm="33000"/>
 </p:sld>
 </file>
 
@@ -3301,7 +3301,7 @@
   <p:clrMapOvr>
     <a:masterClrMapping/>
   </p:clrMapOvr>
-  <p:transition advClick="1" advTm="30000"/>
+  <p:transition advClick="1" advTm="44000"/>
 </p:sld>
 </file>
 
@@ -3344,7 +3344,7 @@
   <p:clrMapOvr>
     <a:masterClrMapping/>
   </p:clrMapOvr>
-  <p:transition advClick="1" advTm="12000"/>
+  <p:transition advClick="1" advTm="11000"/>
 </p:sld>
 </file>
 
@@ -3430,7 +3430,7 @@
   <p:clrMapOvr>
     <a:masterClrMapping/>
   </p:clrMapOvr>
-  <p:transition advClick="1" advTm="24000"/>
+  <p:transition advClick="1" advTm="15000"/>
 </p:sld>
 </file>
 
@@ -3473,7 +3473,7 @@
   <p:clrMapOvr>
     <a:masterClrMapping/>
   </p:clrMapOvr>
-  <p:transition advClick="1" advTm="18000"/>
+  <p:transition advClick="1" advTm="23000"/>
 </p:sld>
 </file>
 
@@ -3559,7 +3559,7 @@
   <p:clrMapOvr>
     <a:masterClrMapping/>
   </p:clrMapOvr>
-  <p:transition advClick="1" advTm="12000"/>
+  <p:transition advClick="1" advTm="19000"/>
 </p:sld>
 </file>
 
@@ -3602,7 +3602,7 @@
   <p:clrMapOvr>
     <a:masterClrMapping/>
   </p:clrMapOvr>
-  <p:transition advClick="1" advTm="20000"/>
+  <p:transition advClick="1" advTm="14000"/>
 </p:sld>
 </file>
 
@@ -3645,7 +3645,7 @@
   <p:clrMapOvr>
     <a:masterClrMapping/>
   </p:clrMapOvr>
-  <p:transition advClick="1" advTm="35000"/>
+  <p:transition advClick="1" advTm="21000"/>
 </p:sld>
 </file>
 

</xml_diff>

<commit_message>
Add expressive narration directions timed pauses and guiding slide questions
</commit_message>
<xml_diff>
--- a/submission/PathwayAI_Final_Backup_Slides.pptx
+++ b/submission/PathwayAI_Final_Backup_Slides.pptx
@@ -3215,7 +3215,7 @@
   <p:clrMapOvr>
     <a:masterClrMapping/>
   </p:clrMapOvr>
-  <p:transition advClick="1" advTm="34000"/>
+  <p:transition advClick="1" advTm="33000"/>
 </p:sld>
 </file>
 
@@ -3258,7 +3258,7 @@
   <p:clrMapOvr>
     <a:masterClrMapping/>
   </p:clrMapOvr>
-  <p:transition advClick="1" advTm="33000"/>
+  <p:transition advClick="1" advTm="34000"/>
 </p:sld>
 </file>
 

</xml_diff>

<commit_message>
Refocus demo narration on patient value and concrete community planning
</commit_message>
<xml_diff>
--- a/submission/PathwayAI_Final_Backup_Slides.pptx
+++ b/submission/PathwayAI_Final_Backup_Slides.pptx
@@ -3215,7 +3215,7 @@
   <p:clrMapOvr>
     <a:masterClrMapping/>
   </p:clrMapOvr>
-  <p:transition advClick="1" advTm="33000"/>
+  <p:transition advClick="1" advTm="34000"/>
 </p:sld>
 </file>
 
@@ -3258,7 +3258,7 @@
   <p:clrMapOvr>
     <a:masterClrMapping/>
   </p:clrMapOvr>
-  <p:transition advClick="1" advTm="34000"/>
+  <p:transition advClick="1" advTm="28000"/>
 </p:sld>
 </file>
 
@@ -3344,7 +3344,7 @@
   <p:clrMapOvr>
     <a:masterClrMapping/>
   </p:clrMapOvr>
-  <p:transition advClick="1" advTm="11000"/>
+  <p:transition advClick="1" advTm="13000"/>
 </p:sld>
 </file>
 
@@ -3430,7 +3430,7 @@
   <p:clrMapOvr>
     <a:masterClrMapping/>
   </p:clrMapOvr>
-  <p:transition advClick="1" advTm="15000"/>
+  <p:transition advClick="1" advTm="17000"/>
 </p:sld>
 </file>
 
@@ -3473,7 +3473,7 @@
   <p:clrMapOvr>
     <a:masterClrMapping/>
   </p:clrMapOvr>
-  <p:transition advClick="1" advTm="23000"/>
+  <p:transition advClick="1" advTm="22000"/>
 </p:sld>
 </file>
 
@@ -3602,7 +3602,7 @@
   <p:clrMapOvr>
     <a:masterClrMapping/>
   </p:clrMapOvr>
-  <p:transition advClick="1" advTm="14000"/>
+  <p:transition advClick="1" advTm="16000"/>
 </p:sld>
 </file>
 

</xml_diff>

<commit_message>
Clarify CDC dataset grouping and state and study sources on county slide
</commit_message>
<xml_diff>
--- a/submission/PathwayAI_Final_Backup_Slides.pptx
+++ b/submission/PathwayAI_Final_Backup_Slides.pptx
@@ -3301,7 +3301,7 @@
   <p:clrMapOvr>
     <a:masterClrMapping/>
   </p:clrMapOvr>
-  <p:transition advClick="1" advTm="44000"/>
+  <p:transition advClick="1" advTm="43000"/>
 </p:sld>
 </file>
 
@@ -3473,7 +3473,7 @@
   <p:clrMapOvr>
     <a:masterClrMapping/>
   </p:clrMapOvr>
-  <p:transition advClick="1" advTm="22000"/>
+  <p:transition advClick="1" advTm="24000"/>
 </p:sld>
 </file>
 
@@ -3645,7 +3645,7 @@
   <p:clrMapOvr>
     <a:masterClrMapping/>
   </p:clrMapOvr>
-  <p:transition advClick="1" advTm="21000"/>
+  <p:transition advClick="1" advTm="20000"/>
 </p:sld>
 </file>
 

</xml_diff>

<commit_message>
Use natural outdoor-planning language in demo narration and slide
</commit_message>
<xml_diff>
--- a/submission/PathwayAI_Final_Backup_Slides.pptx
+++ b/submission/PathwayAI_Final_Backup_Slides.pptx
@@ -3301,7 +3301,7 @@
   <p:clrMapOvr>
     <a:masterClrMapping/>
   </p:clrMapOvr>
-  <p:transition advClick="1" advTm="43000"/>
+  <p:transition advClick="1" advTm="42000"/>
 </p:sld>
 </file>
 
@@ -3559,7 +3559,7 @@
   <p:clrMapOvr>
     <a:masterClrMapping/>
   </p:clrMapOvr>
-  <p:transition advClick="1" advTm="19000"/>
+  <p:transition advClick="1" advTm="20000"/>
 </p:sld>
 </file>
 

</xml_diff>

<commit_message>
Focus demo on strengths and move detailed qualifications into Q and A
</commit_message>
<xml_diff>
--- a/submission/PathwayAI_Final_Backup_Slides.pptx
+++ b/submission/PathwayAI_Final_Backup_Slides.pptx
@@ -3172,7 +3172,7 @@
   <p:clrMapOvr>
     <a:masterClrMapping/>
   </p:clrMapOvr>
-  <p:transition advClick="1" advTm="22000"/>
+  <p:transition advClick="1" advTm="24000"/>
 </p:sld>
 </file>
 
@@ -3215,7 +3215,7 @@
   <p:clrMapOvr>
     <a:masterClrMapping/>
   </p:clrMapOvr>
-  <p:transition advClick="1" advTm="34000"/>
+  <p:transition advClick="1" advTm="35000"/>
 </p:sld>
 </file>
 
@@ -3258,7 +3258,7 @@
   <p:clrMapOvr>
     <a:masterClrMapping/>
   </p:clrMapOvr>
-  <p:transition advClick="1" advTm="28000"/>
+  <p:transition advClick="1" advTm="24000"/>
 </p:sld>
 </file>
 
@@ -3301,7 +3301,7 @@
   <p:clrMapOvr>
     <a:masterClrMapping/>
   </p:clrMapOvr>
-  <p:transition advClick="1" advTm="42000"/>
+  <p:transition advClick="1" advTm="41000"/>
 </p:sld>
 </file>
 
@@ -3344,7 +3344,7 @@
   <p:clrMapOvr>
     <a:masterClrMapping/>
   </p:clrMapOvr>
-  <p:transition advClick="1" advTm="13000"/>
+  <p:transition advClick="1" advTm="21000"/>
 </p:sld>
 </file>
 
@@ -3430,7 +3430,7 @@
   <p:clrMapOvr>
     <a:masterClrMapping/>
   </p:clrMapOvr>
-  <p:transition advClick="1" advTm="17000"/>
+  <p:transition advClick="1" advTm="18000"/>
 </p:sld>
 </file>
 
@@ -3473,7 +3473,7 @@
   <p:clrMapOvr>
     <a:masterClrMapping/>
   </p:clrMapOvr>
-  <p:transition advClick="1" advTm="24000"/>
+  <p:transition advClick="1" advTm="25000"/>
 </p:sld>
 </file>
 
@@ -3559,7 +3559,7 @@
   <p:clrMapOvr>
     <a:masterClrMapping/>
   </p:clrMapOvr>
-  <p:transition advClick="1" advTm="20000"/>
+  <p:transition advClick="1" advTm="12000"/>
 </p:sld>
 </file>
 
@@ -3602,7 +3602,7 @@
   <p:clrMapOvr>
     <a:masterClrMapping/>
   </p:clrMapOvr>
-  <p:transition advClick="1" advTm="16000"/>
+  <p:transition advClick="1" advTm="15000"/>
 </p:sld>
 </file>
 
@@ -3645,7 +3645,7 @@
   <p:clrMapOvr>
     <a:masterClrMapping/>
   </p:clrMapOvr>
-  <p:transition advClick="1" advTm="20000"/>
+  <p:transition advClick="1" advTm="21000"/>
 </p:sld>
 </file>
 

</xml_diff>

<commit_message>
Connect language-access demo to Orange County Census context
</commit_message>
<xml_diff>
--- a/submission/PathwayAI_Final_Backup_Slides.pptx
+++ b/submission/PathwayAI_Final_Backup_Slides.pptx
@@ -3172,7 +3172,7 @@
   <p:clrMapOvr>
     <a:masterClrMapping/>
   </p:clrMapOvr>
-  <p:transition advClick="1" advTm="24000"/>
+  <p:transition advClick="1" advTm="29000"/>
 </p:sld>
 </file>
 
@@ -3215,7 +3215,7 @@
   <p:clrMapOvr>
     <a:masterClrMapping/>
   </p:clrMapOvr>
-  <p:transition advClick="1" advTm="35000"/>
+  <p:transition advClick="1" advTm="34000"/>
 </p:sld>
 </file>
 
@@ -3301,7 +3301,7 @@
   <p:clrMapOvr>
     <a:masterClrMapping/>
   </p:clrMapOvr>
-  <p:transition advClick="1" advTm="41000"/>
+  <p:transition advClick="1" advTm="40000"/>
 </p:sld>
 </file>
 
@@ -3344,7 +3344,7 @@
   <p:clrMapOvr>
     <a:masterClrMapping/>
   </p:clrMapOvr>
-  <p:transition advClick="1" advTm="21000"/>
+  <p:transition advClick="1" advTm="20000"/>
 </p:sld>
 </file>
 
@@ -3430,7 +3430,7 @@
   <p:clrMapOvr>
     <a:masterClrMapping/>
   </p:clrMapOvr>
-  <p:transition advClick="1" advTm="18000"/>
+  <p:transition advClick="1" advTm="17000"/>
 </p:sld>
 </file>
 
@@ -3645,7 +3645,7 @@
   <p:clrMapOvr>
     <a:masterClrMapping/>
   </p:clrMapOvr>
-  <p:transition advClick="1" advTm="21000"/>
+  <p:transition advClick="1" advTm="20000"/>
 </p:sld>
 </file>
 

</xml_diff>